<commit_message>
Presentación de péptidos: portada sin «masterclass 1 de 3»; anexo depurado
Co-Authored-By: Claude Sonnet 5.5 <noreply@anthropic.com>
Claude-Session: https://claude.ai/code/session_01H7jfTyMshQcw7Zt2f1LbsZ
</commit_message>
<xml_diff>
--- a/assets/guia-peptidos-obesidad-presentacion.pptx
+++ b/assets/guia-peptidos-obesidad-presentacion.pptx
@@ -5441,7 +5441,7 @@
         <p:spPr>
           <a:xfrm>
             <a:off x="640080" y="640080"/>
-            <a:ext cx="3994647" cy="310896"/>
+            <a:ext cx="2614635" cy="310896"/>
           </a:xfrm>
           <a:prstGeom prst="roundRect">
             <a:avLst>
@@ -5487,7 +5487,7 @@
         <p:spPr>
           <a:xfrm>
             <a:off x="640080" y="640080"/>
-            <a:ext cx="3994647" cy="310896"/>
+            <a:ext cx="2614635" cy="310896"/>
           </a:xfrm>
           <a:prstGeom prst="rect">
             <a:avLst/>
@@ -5512,7 +5512,7 @@
                 </a:solidFill>
                 <a:latin typeface="Archivo"/>
               </a:rPr>
-              <a:t>MASTERCLASS GRATUITA EN VIVO · 1 DE 3</a:t>
+              <a:t>GUÍA PARA PROFESIONALES</a:t>
             </a:r>
           </a:p>
         </p:txBody>

</xml_diff>